<commit_message>
Update short presentation: added more slides with concise content
</commit_message>
<xml_diff>
--- a/Final Documents/TQM_Project_Presentation_BBAT104_2410301049.pptx
+++ b/Final Documents/TQM_Project_Presentation_BBAT104_2410301049.pptx
@@ -9,6 +9,11 @@
     <p:sldId id="257" r:id="rId8"/>
     <p:sldId id="258" r:id="rId9"/>
     <p:sldId id="259" r:id="rId10"/>
+    <p:sldId id="260" r:id="rId11"/>
+    <p:sldId id="261" r:id="rId12"/>
+    <p:sldId id="262" r:id="rId13"/>
+    <p:sldId id="263" r:id="rId14"/>
+    <p:sldId id="264" r:id="rId15"/>
   </p:sldIdLst>
   <p:sldSz cx="12191695" cy="6858000" type="screen4x3"/>
   <p:notesSz cx="6858000" cy="9144000"/>
@@ -3162,7 +3167,7 @@
               </a:defRPr>
             </a:pPr>
             <a:r>
-              <a:t>Reviews 1 &amp; 2 Presentation — Academic Session 2026–27</a:t>
+              <a:t>BBAT104 Course Project (Reviews 1 &amp; 2) — Session 2026–27</a:t>
             </a:r>
           </a:p>
         </p:txBody>
@@ -3346,7 +3351,7 @@
               </a:defRPr>
             </a:pPr>
             <a:r>
-              <a:t>The Problem &amp; TQM Solution</a:t>
+              <a:t>The Problem: Latency in Quiz Platforms</a:t>
             </a:r>
           </a:p>
         </p:txBody>
@@ -3404,7 +3409,7 @@
               </a:defRPr>
             </a:pPr>
             <a:r>
-              <a:t>The Problem (Root Cause)</a:t>
+              <a:t>Root Causes of Sluggish Software</a:t>
             </a:r>
           </a:p>
           <a:p>
@@ -3420,7 +3425,7 @@
               </a:defRPr>
             </a:pPr>
             <a:r>
-              <a:t>• Full table scans on unindexed tables freeze the UI during exam hours.</a:t>
+              <a:t>• Full Table Scans: O(N) sequential search through every disk block.</a:t>
             </a:r>
           </a:p>
           <a:p>
@@ -3436,7 +3441,7 @@
               </a:defRPr>
             </a:pPr>
             <a:r>
-              <a:t>• Repetitive disk aggregations (COUNT, AVG) slow down dashboard loading.</a:t>
+              <a:t>• Repetitive Disk Reads: Computing COUNT &amp; AVG directly on disk.</a:t>
             </a:r>
           </a:p>
           <a:p>
@@ -3452,7 +3457,7 @@
               </a:defRPr>
             </a:pPr>
             <a:r>
-              <a:t>• Loading all past attempts at once exhausts application memory.</a:t>
+              <a:t>• Unbounded Data Dumps: Loading 1,000s of attempt rows into RAM.</a:t>
             </a:r>
           </a:p>
           <a:p>
@@ -3468,7 +3473,7 @@
               </a:defRPr>
             </a:pPr>
             <a:r>
-              <a:t>• Student stress: 'Did my test submit before time ran out?'</a:t>
+              <a:t>• Single-Thread Freezes: Disk wait halts UI window redraws.</a:t>
             </a:r>
           </a:p>
         </p:txBody>
@@ -3488,7 +3493,7 @@
             <a:avLst/>
           </a:prstGeom>
           <a:solidFill>
-            <a:srgbClr val="0284C7"/>
+            <a:srgbClr val="EF4444"/>
           </a:solidFill>
           <a:ln>
             <a:noFill/>
@@ -3531,11 +3536,11 @@
             <a:avLst/>
           </a:prstGeom>
           <a:solidFill>
-            <a:srgbClr val="F0FDF4"/>
+            <a:srgbClr val="FFFFFF"/>
           </a:solidFill>
           <a:ln w="19050">
             <a:solidFill>
-              <a:srgbClr val="10955A"/>
+              <a:srgbClr val="EF4444"/>
             </a:solidFill>
           </a:ln>
         </p:spPr>
@@ -3563,13 +3568,13 @@
               </a:spcAft>
               <a:defRPr sz="2200" b="1">
                 <a:solidFill>
-                  <a:srgbClr val="10955A"/>
-                </a:solidFill>
-                <a:latin typeface="Segoe UI"/>
-              </a:defRPr>
-            </a:pPr>
-            <a:r>
-              <a:t>TQM Architectural Fix (Deming 85/15)</a:t>
+                  <a:srgbClr val="B91C1C"/>
+                </a:solidFill>
+                <a:latin typeface="Segoe UI"/>
+              </a:defRPr>
+            </a:pPr>
+            <a:r>
+              <a:t>Impact on Users (Quality Failure)</a:t>
             </a:r>
           </a:p>
           <a:p>
@@ -3585,7 +3590,7 @@
               </a:defRPr>
             </a:pPr>
             <a:r>
-              <a:t>• 85% of delays are architectural flaws, not user or network mistakes.</a:t>
+              <a:t>• Student Anxiety: 'Did my test submit or did my timer expire?'</a:t>
             </a:r>
           </a:p>
           <a:p>
@@ -3601,7 +3606,7 @@
               </a:defRPr>
             </a:pPr>
             <a:r>
-              <a:t>• B-Tree composite indexes eliminate slow table scans entirely.</a:t>
+              <a:t>• Teacher Frustration: Sluggish dashboard opening across cohorts.</a:t>
             </a:r>
           </a:p>
           <a:p>
@@ -3617,7 +3622,7 @@
               </a:defRPr>
             </a:pPr>
             <a:r>
-              <a:t>• In-memory RAM caching serves repeated queries in 0.010 ms.</a:t>
+              <a:t>• Compromised Transparency: Delay violates fair exam standards.</a:t>
             </a:r>
           </a:p>
           <a:p>
@@ -3633,7 +3638,7 @@
               </a:defRPr>
             </a:pPr>
             <a:r>
-              <a:t>• Server-side pagination streams reports in small, fast chunks.</a:t>
+              <a:t>• Evaluation Risk: Lack of empirical response time telemetry.</a:t>
             </a:r>
           </a:p>
         </p:txBody>
@@ -3711,7 +3716,7 @@
               </a:defRPr>
             </a:pPr>
             <a:r>
-              <a:t>Q05 Features &amp; Poka-Yoke Controls</a:t>
+              <a:t>TQM Philosophy &amp; Deming's 85/15 Rule</a:t>
             </a:r>
           </a:p>
         </p:txBody>
@@ -3731,11 +3736,11 @@
             <a:avLst/>
           </a:prstGeom>
           <a:solidFill>
-            <a:srgbClr val="EFF6FF"/>
+            <a:srgbClr val="FFFFFF"/>
           </a:solidFill>
           <a:ln w="19050">
             <a:solidFill>
-              <a:srgbClr val="0284C7"/>
+              <a:srgbClr val="1E3A5F"/>
             </a:solidFill>
           </a:ln>
         </p:spPr>
@@ -3763,13 +3768,13 @@
               </a:spcAft>
               <a:defRPr sz="2200" b="1">
                 <a:solidFill>
-                  <a:srgbClr val="0284C7"/>
-                </a:solidFill>
-                <a:latin typeface="Segoe UI"/>
-              </a:defRPr>
-            </a:pPr>
-            <a:r>
-              <a:t>5 Quality Features Built (Q05)</a:t>
+                  <a:srgbClr val="1E3A5F"/>
+                </a:solidFill>
+                <a:latin typeface="Segoe UI"/>
+              </a:defRPr>
+            </a:pPr>
+            <a:r>
+              <a:t>Deming's 85/15 Rule Explained</a:t>
             </a:r>
           </a:p>
           <a:p>
@@ -3785,7 +3790,7 @@
               </a:defRPr>
             </a:pPr>
             <a:r>
-              <a:t>• 1. Fast Search: Indexed, debounced catalog search (3.3 ms).</a:t>
+              <a:t>• 85% of software quality flaws stem from system architecture.</a:t>
             </a:r>
           </a:p>
           <a:p>
@@ -3801,7 +3806,7 @@
               </a:defRPr>
             </a:pPr>
             <a:r>
-              <a:t>• 2. Quick Navigation: Keyboard shortcuts (Alt+D/Q/M/R) with 0 ms lag.</a:t>
+              <a:t>• Only 15% are worker, human, or user errors.</a:t>
             </a:r>
           </a:p>
           <a:p>
@@ -3817,7 +3822,7 @@
               </a:defRPr>
             </a:pPr>
             <a:r>
-              <a:t>• 3. Cached Dashboard: 60s RAM buffer avoids repeated disk reads.</a:t>
+              <a:t>• Slow response times are NOT caused by slow user hardware.</a:t>
             </a:r>
           </a:p>
           <a:p>
@@ -3833,23 +3838,7 @@
               </a:defRPr>
             </a:pPr>
             <a:r>
-              <a:t>• 4. DB Indexing: 4 B-Tree indexes convert scans to fast lookups.</a:t>
-            </a:r>
-          </a:p>
-          <a:p>
-            <a:pPr>
-              <a:spcAft>
-                <a:spcPts val="800"/>
-              </a:spcAft>
-              <a:defRPr sz="2000">
-                <a:solidFill>
-                  <a:srgbClr val="0F172A"/>
-                </a:solidFill>
-                <a:latin typeface="Segoe UI"/>
-              </a:defRPr>
-            </a:pPr>
-            <a:r>
-              <a:t>• 5. Paginated Reports: LIMIT/OFFSET streaming keeps memory small.</a:t>
+              <a:t>• Missing indexes &amp; uncached queries are architectural bugs.</a:t>
             </a:r>
           </a:p>
         </p:txBody>
@@ -3912,11 +3901,11 @@
             <a:avLst/>
           </a:prstGeom>
           <a:solidFill>
-            <a:srgbClr val="FFFFFF"/>
+            <a:srgbClr val="F0FDF4"/>
           </a:solidFill>
           <a:ln w="19050">
             <a:solidFill>
-              <a:srgbClr val="1E3A5F"/>
+              <a:srgbClr val="10955A"/>
             </a:solidFill>
           </a:ln>
         </p:spPr>
@@ -3944,13 +3933,13 @@
               </a:spcAft>
               <a:defRPr sz="2200" b="1">
                 <a:solidFill>
-                  <a:srgbClr val="1E3A5F"/>
-                </a:solidFill>
-                <a:latin typeface="Segoe UI"/>
-              </a:defRPr>
-            </a:pPr>
-            <a:r>
-              <a:t>Poka-Yoke (Mistake-Proofing)</a:t>
+                  <a:srgbClr val="10955A"/>
+                </a:solidFill>
+                <a:latin typeface="Segoe UI"/>
+              </a:defRPr>
+            </a:pPr>
+            <a:r>
+              <a:t>The TQM Kaizen Solution</a:t>
             </a:r>
           </a:p>
           <a:p>
@@ -3966,7 +3955,7 @@
               </a:defRPr>
             </a:pPr>
             <a:r>
-              <a:t>• Restricted Keys: Answer keys strictly locked to ['A', 'B', 'C', 'D'].</a:t>
+              <a:t>• Fix root causes architecturally using B-Tree indexing.</a:t>
             </a:r>
           </a:p>
           <a:p>
@@ -3982,7 +3971,7 @@
               </a:defRPr>
             </a:pPr>
             <a:r>
-              <a:t>• Blank Protection: Empty questions and options cannot be saved.</a:t>
+              <a:t>• Eliminate repeated disk I/O using in-memory RAM caching.</a:t>
             </a:r>
           </a:p>
           <a:p>
@@ -3998,7 +3987,7 @@
               </a:defRPr>
             </a:pPr>
             <a:r>
-              <a:t>• Double-Click Guard: Submit button disables to stop duplicate attempts.</a:t>
+              <a:t>• Stream reports in chunks using server-side pagination.</a:t>
             </a:r>
           </a:p>
           <a:p>
@@ -4014,7 +4003,7 @@
               </a:defRPr>
             </a:pPr>
             <a:r>
-              <a:t>• Admin Protection: Only teachers/admins can delete active exams.</a:t>
+              <a:t>• Measure microsecond latency empirically against strict SLAs.</a:t>
             </a:r>
           </a:p>
         </p:txBody>
@@ -4092,7 +4081,1646 @@
               </a:defRPr>
             </a:pPr>
             <a:r>
-              <a:t>Empirical Results &amp; Test Verification</a:t>
+              <a:t>Voice of Customer (VoC) → CTQ Metrics</a:t>
+            </a:r>
+          </a:p>
+        </p:txBody>
+      </p:sp>
+      <p:sp>
+        <p:nvSpPr>
+          <p:cNvPr id="3" name="Rounded Rectangle 2"/>
+          <p:cNvSpPr/>
+          <p:nvPr/>
+        </p:nvSpPr>
+        <p:spPr>
+          <a:xfrm>
+            <a:off x="731520" y="1645920"/>
+            <a:ext cx="5120640" cy="4572000"/>
+          </a:xfrm>
+          <a:prstGeom prst="roundRect">
+            <a:avLst/>
+          </a:prstGeom>
+          <a:solidFill>
+            <a:srgbClr val="FFFFFF"/>
+          </a:solidFill>
+          <a:ln w="19050">
+            <a:solidFill>
+              <a:srgbClr val="1E3A5F"/>
+            </a:solidFill>
+          </a:ln>
+        </p:spPr>
+        <p:style>
+          <a:lnRef idx="1">
+            <a:schemeClr val="accent1"/>
+          </a:lnRef>
+          <a:fillRef idx="3">
+            <a:schemeClr val="accent1"/>
+          </a:fillRef>
+          <a:effectRef idx="2">
+            <a:schemeClr val="accent1"/>
+          </a:effectRef>
+          <a:fontRef idx="minor">
+            <a:schemeClr val="lt1"/>
+          </a:fontRef>
+        </p:style>
+        <p:txBody>
+          <a:bodyPr rtlCol="0" anchor="t" wrap="square" tIns="164592" lIns="182880" rIns="182880" bIns="164592"/>
+          <a:lstStyle/>
+          <a:p>
+            <a:pPr algn="ctr">
+              <a:spcAft>
+                <a:spcPts val="800"/>
+              </a:spcAft>
+              <a:defRPr sz="2200" b="1">
+                <a:solidFill>
+                  <a:srgbClr val="1E3A5F"/>
+                </a:solidFill>
+                <a:latin typeface="Segoe UI"/>
+              </a:defRPr>
+            </a:pPr>
+            <a:r>
+              <a:t>Voice of Customer (Raw Need)</a:t>
+            </a:r>
+          </a:p>
+          <a:p>
+            <a:pPr>
+              <a:spcAft>
+                <a:spcPts val="800"/>
+              </a:spcAft>
+              <a:defRPr sz="2000">
+                <a:solidFill>
+                  <a:srgbClr val="0F172A"/>
+                </a:solidFill>
+                <a:latin typeface="Segoe UI"/>
+              </a:defRPr>
+            </a:pPr>
+            <a:r>
+              <a:t>• Student: 'Submitting a quiz hangs — I don't know if it's saved.'</a:t>
+            </a:r>
+          </a:p>
+          <a:p>
+            <a:pPr>
+              <a:spcAft>
+                <a:spcPts val="800"/>
+              </a:spcAft>
+              <a:defRPr sz="2000">
+                <a:solidFill>
+                  <a:srgbClr val="0F172A"/>
+                </a:solidFill>
+                <a:latin typeface="Segoe UI"/>
+              </a:defRPr>
+            </a:pPr>
+            <a:r>
+              <a:t>• Student: 'Searching through quiz categories takes too long.'</a:t>
+            </a:r>
+          </a:p>
+          <a:p>
+            <a:pPr>
+              <a:spcAft>
+                <a:spcPts val="800"/>
+              </a:spcAft>
+              <a:defRPr sz="2000">
+                <a:solidFill>
+                  <a:srgbClr val="0F172A"/>
+                </a:solidFill>
+                <a:latin typeface="Segoe UI"/>
+              </a:defRPr>
+            </a:pPr>
+            <a:r>
+              <a:t>• Teacher: 'Dashboard freezes when 500+ attempts are logged.'</a:t>
+            </a:r>
+          </a:p>
+          <a:p>
+            <a:pPr>
+              <a:spcAft>
+                <a:spcPts val="800"/>
+              </a:spcAft>
+              <a:defRPr sz="2000">
+                <a:solidFill>
+                  <a:srgbClr val="0F172A"/>
+                </a:solidFill>
+                <a:latin typeface="Segoe UI"/>
+              </a:defRPr>
+            </a:pPr>
+            <a:r>
+              <a:t>• Auditor: 'Need empirical proof of compliance with speed limits.'</a:t>
+            </a:r>
+          </a:p>
+        </p:txBody>
+      </p:sp>
+      <p:sp>
+        <p:nvSpPr>
+          <p:cNvPr id="4" name="Right Arrow 3"/>
+          <p:cNvSpPr/>
+          <p:nvPr/>
+        </p:nvSpPr>
+        <p:spPr>
+          <a:xfrm>
+            <a:off x="5943600" y="3749039"/>
+            <a:ext cx="365760" cy="320040"/>
+          </a:xfrm>
+          <a:prstGeom prst="rightArrow">
+            <a:avLst/>
+          </a:prstGeom>
+          <a:solidFill>
+            <a:srgbClr val="0284C7"/>
+          </a:solidFill>
+          <a:ln>
+            <a:noFill/>
+          </a:ln>
+        </p:spPr>
+        <p:style>
+          <a:lnRef idx="1">
+            <a:schemeClr val="accent1"/>
+          </a:lnRef>
+          <a:fillRef idx="3">
+            <a:schemeClr val="accent1"/>
+          </a:fillRef>
+          <a:effectRef idx="2">
+            <a:schemeClr val="accent1"/>
+          </a:effectRef>
+          <a:fontRef idx="minor">
+            <a:schemeClr val="lt1"/>
+          </a:fontRef>
+        </p:style>
+        <p:txBody>
+          <a:bodyPr rtlCol="0" anchor="ctr"/>
+          <a:lstStyle/>
+          <a:p>
+            <a:pPr algn="ctr"/>
+          </a:p>
+        </p:txBody>
+      </p:sp>
+      <p:sp>
+        <p:nvSpPr>
+          <p:cNvPr id="5" name="Rounded Rectangle 4"/>
+          <p:cNvSpPr/>
+          <p:nvPr/>
+        </p:nvSpPr>
+        <p:spPr>
+          <a:xfrm>
+            <a:off x="6400800" y="1645920"/>
+            <a:ext cx="5029200" cy="4572000"/>
+          </a:xfrm>
+          <a:prstGeom prst="roundRect">
+            <a:avLst/>
+          </a:prstGeom>
+          <a:solidFill>
+            <a:srgbClr val="EFF6FF"/>
+          </a:solidFill>
+          <a:ln w="19050">
+            <a:solidFill>
+              <a:srgbClr val="0284C7"/>
+            </a:solidFill>
+          </a:ln>
+        </p:spPr>
+        <p:style>
+          <a:lnRef idx="1">
+            <a:schemeClr val="accent1"/>
+          </a:lnRef>
+          <a:fillRef idx="3">
+            <a:schemeClr val="accent1"/>
+          </a:fillRef>
+          <a:effectRef idx="2">
+            <a:schemeClr val="accent1"/>
+          </a:effectRef>
+          <a:fontRef idx="minor">
+            <a:schemeClr val="lt1"/>
+          </a:fontRef>
+        </p:style>
+        <p:txBody>
+          <a:bodyPr rtlCol="0" anchor="t" wrap="square" tIns="164592" lIns="182880" rIns="182880" bIns="164592"/>
+          <a:lstStyle/>
+          <a:p>
+            <a:pPr algn="ctr">
+              <a:spcAft>
+                <a:spcPts val="800"/>
+              </a:spcAft>
+              <a:defRPr sz="2200" b="1">
+                <a:solidFill>
+                  <a:srgbClr val="0284C7"/>
+                </a:solidFill>
+                <a:latin typeface="Segoe UI"/>
+              </a:defRPr>
+            </a:pPr>
+            <a:r>
+              <a:t>Critical-to-Quality (CTQ) Engineering Targets</a:t>
+            </a:r>
+          </a:p>
+          <a:p>
+            <a:pPr>
+              <a:spcAft>
+                <a:spcPts val="800"/>
+              </a:spcAft>
+              <a:defRPr sz="2000">
+                <a:solidFill>
+                  <a:srgbClr val="0F172A"/>
+                </a:solidFill>
+                <a:latin typeface="Segoe UI"/>
+              </a:defRPr>
+            </a:pPr>
+            <a:r>
+              <a:t>• Catalog Fast Search: Target &lt; 25 ms | USL ≤ 40.0 ms</a:t>
+            </a:r>
+          </a:p>
+          <a:p>
+            <a:pPr>
+              <a:spcAft>
+                <a:spcPts val="800"/>
+              </a:spcAft>
+              <a:defRPr sz="2000">
+                <a:solidFill>
+                  <a:srgbClr val="0F172A"/>
+                </a:solidFill>
+                <a:latin typeface="Segoe UI"/>
+              </a:defRPr>
+            </a:pPr>
+            <a:r>
+              <a:t>• Question Load into RAM: Target &lt; 10 ms | USL ≤ 50.0 ms</a:t>
+            </a:r>
+          </a:p>
+          <a:p>
+            <a:pPr>
+              <a:spcAft>
+                <a:spcPts val="800"/>
+              </a:spcAft>
+              <a:defRPr sz="2000">
+                <a:solidFill>
+                  <a:srgbClr val="0F172A"/>
+                </a:solidFill>
+                <a:latin typeface="Segoe UI"/>
+              </a:defRPr>
+            </a:pPr>
+            <a:r>
+              <a:t>• Atomic Submit &amp; Scoring: Target &lt; 60 ms | USL ≤ 100.0 ms</a:t>
+            </a:r>
+          </a:p>
+          <a:p>
+            <a:pPr>
+              <a:spcAft>
+                <a:spcPts val="800"/>
+              </a:spcAft>
+              <a:defRPr sz="2000">
+                <a:solidFill>
+                  <a:srgbClr val="0F172A"/>
+                </a:solidFill>
+                <a:latin typeface="Segoe UI"/>
+              </a:defRPr>
+            </a:pPr>
+            <a:r>
+              <a:t>• Cached Dashboard Read: Target &lt; 5 ms | USL ≤ 15.0 ms</a:t>
+            </a:r>
+          </a:p>
+          <a:p>
+            <a:pPr>
+              <a:spcAft>
+                <a:spcPts val="800"/>
+              </a:spcAft>
+              <a:defRPr sz="2000">
+                <a:solidFill>
+                  <a:srgbClr val="0F172A"/>
+                </a:solidFill>
+                <a:latin typeface="Segoe UI"/>
+              </a:defRPr>
+            </a:pPr>
+            <a:r>
+              <a:t>• Paginated Report Stream: Target &lt; 25 ms | USL ≤ 50.0 ms</a:t>
+            </a:r>
+          </a:p>
+        </p:txBody>
+      </p:sp>
+    </p:spTree>
+  </p:cSld>
+  <p:clrMapOvr>
+    <a:masterClrMapping/>
+  </p:clrMapOvr>
+</p:sld>
+</file>
+
+<file path=ppt/slides/slide5.xml><?xml version="1.0" encoding="utf-8"?>
+<p:sld xmlns:a="http://schemas.openxmlformats.org/drawingml/2006/main" xmlns:p="http://schemas.openxmlformats.org/presentationml/2006/main" xmlns:r="http://schemas.openxmlformats.org/officeDocument/2006/relationships">
+  <p:cSld>
+    <p:bg>
+      <p:bgPr>
+        <a:solidFill>
+          <a:srgbClr val="F1F5F9"/>
+        </a:solidFill>
+        <a:effectLst/>
+      </p:bgPr>
+    </p:bg>
+    <p:spTree>
+      <p:nvGrpSpPr>
+        <p:cNvPr id="1" name=""/>
+        <p:cNvGrpSpPr/>
+        <p:nvPr/>
+      </p:nvGrpSpPr>
+      <p:grpSpPr/>
+      <p:sp>
+        <p:nvSpPr>
+          <p:cNvPr id="2" name="TextBox 1"/>
+          <p:cNvSpPr txBox="1"/>
+          <p:nvPr/>
+        </p:nvSpPr>
+        <p:spPr>
+          <a:xfrm>
+            <a:off x="731520" y="365760"/>
+            <a:ext cx="10698480" cy="1097280"/>
+          </a:xfrm>
+          <a:prstGeom prst="rect">
+            <a:avLst/>
+          </a:prstGeom>
+          <a:noFill/>
+        </p:spPr>
+        <p:txBody>
+          <a:bodyPr wrap="square" tIns="0" lIns="0" bIns="0" rIns="0">
+            <a:spAutoFit/>
+          </a:bodyPr>
+          <a:lstStyle/>
+          <a:p>
+            <a:pPr>
+              <a:spcAft>
+                <a:spcPts val="200"/>
+              </a:spcAft>
+              <a:defRPr sz="1300" b="1">
+                <a:solidFill>
+                  <a:srgbClr val="0284C7"/>
+                </a:solidFill>
+                <a:latin typeface="Segoe UI"/>
+              </a:defRPr>
+            </a:pPr>
+            <a:r>
+              <a:t>BBAT104 — TOTAL QUALITY MANAGEMENT (TQM)</a:t>
+            </a:r>
+          </a:p>
+          <a:p>
+            <a:pPr>
+              <a:defRPr sz="3800" b="1">
+                <a:solidFill>
+                  <a:srgbClr val="1E3A5F"/>
+                </a:solidFill>
+                <a:latin typeface="Segoe UI"/>
+              </a:defRPr>
+            </a:pPr>
+            <a:r>
+              <a:t>3-Tier System Architecture (Decoupled Flow)</a:t>
+            </a:r>
+          </a:p>
+        </p:txBody>
+      </p:sp>
+      <p:sp>
+        <p:nvSpPr>
+          <p:cNvPr id="3" name="Rounded Rectangle 2"/>
+          <p:cNvSpPr/>
+          <p:nvPr/>
+        </p:nvSpPr>
+        <p:spPr>
+          <a:xfrm>
+            <a:off x="731520" y="1645920"/>
+            <a:ext cx="10698480" cy="1371600"/>
+          </a:xfrm>
+          <a:prstGeom prst="roundRect">
+            <a:avLst/>
+          </a:prstGeom>
+          <a:solidFill>
+            <a:srgbClr val="FFFFFF"/>
+          </a:solidFill>
+          <a:ln w="19050">
+            <a:solidFill>
+              <a:srgbClr val="1E3A5F"/>
+            </a:solidFill>
+          </a:ln>
+        </p:spPr>
+        <p:style>
+          <a:lnRef idx="1">
+            <a:schemeClr val="accent1"/>
+          </a:lnRef>
+          <a:fillRef idx="3">
+            <a:schemeClr val="accent1"/>
+          </a:fillRef>
+          <a:effectRef idx="2">
+            <a:schemeClr val="accent1"/>
+          </a:effectRef>
+          <a:fontRef idx="minor">
+            <a:schemeClr val="lt1"/>
+          </a:fontRef>
+        </p:style>
+        <p:txBody>
+          <a:bodyPr rtlCol="0" anchor="t" wrap="square" tIns="164592" lIns="182880" rIns="182880" bIns="164592"/>
+          <a:lstStyle/>
+          <a:p>
+            <a:pPr algn="ctr">
+              <a:spcAft>
+                <a:spcPts val="800"/>
+              </a:spcAft>
+              <a:defRPr sz="2200" b="1">
+                <a:solidFill>
+                  <a:srgbClr val="1E3A5F"/>
+                </a:solidFill>
+                <a:latin typeface="Segoe UI"/>
+              </a:defRPr>
+            </a:pPr>
+            <a:r>
+              <a:t>Tier 1: Presentation Layer (UI/UX) — Pre-mounted Containers</a:t>
+            </a:r>
+          </a:p>
+          <a:p>
+            <a:pPr>
+              <a:spcAft>
+                <a:spcPts val="800"/>
+              </a:spcAft>
+              <a:defRPr sz="2000">
+                <a:solidFill>
+                  <a:srgbClr val="0F172A"/>
+                </a:solidFill>
+                <a:latin typeface="Segoe UI"/>
+              </a:defRPr>
+            </a:pPr>
+            <a:r>
+              <a:t>• DashboardView  │  QuizCatalogView  │  ActiveQuizEngine  │  PaginatedReportsView</a:t>
+            </a:r>
+          </a:p>
+          <a:p>
+            <a:pPr>
+              <a:spcAft>
+                <a:spcPts val="800"/>
+              </a:spcAft>
+              <a:defRPr sz="2000">
+                <a:solidFill>
+                  <a:srgbClr val="0F172A"/>
+                </a:solidFill>
+                <a:latin typeface="Segoe UI"/>
+              </a:defRPr>
+            </a:pPr>
+            <a:r>
+              <a:t>• Frames initialized once at startup; Alt+D/Q/M/R switches memory pointers in 0 ms.</a:t>
+            </a:r>
+          </a:p>
+        </p:txBody>
+      </p:sp>
+      <p:sp>
+        <p:nvSpPr>
+          <p:cNvPr id="4" name="Down Arrow 3"/>
+          <p:cNvSpPr/>
+          <p:nvPr/>
+        </p:nvSpPr>
+        <p:spPr>
+          <a:xfrm>
+            <a:off x="5852160" y="3108960"/>
+            <a:ext cx="457200" cy="320040"/>
+          </a:xfrm>
+          <a:prstGeom prst="downArrow">
+            <a:avLst/>
+          </a:prstGeom>
+          <a:solidFill>
+            <a:srgbClr val="0284C7"/>
+          </a:solidFill>
+          <a:ln>
+            <a:noFill/>
+          </a:ln>
+        </p:spPr>
+        <p:style>
+          <a:lnRef idx="1">
+            <a:schemeClr val="accent1"/>
+          </a:lnRef>
+          <a:fillRef idx="3">
+            <a:schemeClr val="accent1"/>
+          </a:fillRef>
+          <a:effectRef idx="2">
+            <a:schemeClr val="accent1"/>
+          </a:effectRef>
+          <a:fontRef idx="minor">
+            <a:schemeClr val="lt1"/>
+          </a:fontRef>
+        </p:style>
+        <p:txBody>
+          <a:bodyPr rtlCol="0" anchor="ctr"/>
+          <a:lstStyle/>
+          <a:p>
+            <a:pPr algn="ctr"/>
+          </a:p>
+        </p:txBody>
+      </p:sp>
+      <p:sp>
+        <p:nvSpPr>
+          <p:cNvPr id="5" name="Rounded Rectangle 4"/>
+          <p:cNvSpPr/>
+          <p:nvPr/>
+        </p:nvSpPr>
+        <p:spPr>
+          <a:xfrm>
+            <a:off x="731520" y="3520440"/>
+            <a:ext cx="10698480" cy="1371600"/>
+          </a:xfrm>
+          <a:prstGeom prst="roundRect">
+            <a:avLst/>
+          </a:prstGeom>
+          <a:solidFill>
+            <a:srgbClr val="EFF6FF"/>
+          </a:solidFill>
+          <a:ln w="19050">
+            <a:solidFill>
+              <a:srgbClr val="0284C7"/>
+            </a:solidFill>
+          </a:ln>
+        </p:spPr>
+        <p:style>
+          <a:lnRef idx="1">
+            <a:schemeClr val="accent1"/>
+          </a:lnRef>
+          <a:fillRef idx="3">
+            <a:schemeClr val="accent1"/>
+          </a:fillRef>
+          <a:effectRef idx="2">
+            <a:schemeClr val="accent1"/>
+          </a:effectRef>
+          <a:fontRef idx="minor">
+            <a:schemeClr val="lt1"/>
+          </a:fontRef>
+        </p:style>
+        <p:txBody>
+          <a:bodyPr rtlCol="0" anchor="t" wrap="square" tIns="164592" lIns="182880" rIns="182880" bIns="164592"/>
+          <a:lstStyle/>
+          <a:p>
+            <a:pPr algn="ctr">
+              <a:spcAft>
+                <a:spcPts val="800"/>
+              </a:spcAft>
+              <a:defRPr sz="2200" b="1">
+                <a:solidFill>
+                  <a:srgbClr val="0284C7"/>
+                </a:solidFill>
+                <a:latin typeface="Segoe UI"/>
+              </a:defRPr>
+            </a:pPr>
+            <a:r>
+              <a:t>Tier 2: Core Logic &amp; Q05 Optimization Engines</a:t>
+            </a:r>
+          </a:p>
+          <a:p>
+            <a:pPr>
+              <a:spcAft>
+                <a:spcPts val="800"/>
+              </a:spcAft>
+              <a:defRPr sz="2000">
+                <a:solidFill>
+                  <a:srgbClr val="0F172A"/>
+                </a:solidFill>
+                <a:latin typeface="Segoe UI"/>
+              </a:defRPr>
+            </a:pPr>
+            <a:r>
+              <a:t>• In-Memory CacheManager (TTL=60s)  │  FastSearch (Debounced)  │  ReportPaginator</a:t>
+            </a:r>
+          </a:p>
+          <a:p>
+            <a:pPr>
+              <a:spcAft>
+                <a:spcPts val="800"/>
+              </a:spcAft>
+              <a:defRPr sz="2000">
+                <a:solidFill>
+                  <a:srgbClr val="0F172A"/>
+                </a:solidFill>
+                <a:latin typeface="Segoe UI"/>
+              </a:defRPr>
+            </a:pPr>
+            <a:r>
+              <a:t>• QuizCRUD Module  │  QuizEngine Auto-Grader  │  Role-Based AuthService</a:t>
+            </a:r>
+          </a:p>
+        </p:txBody>
+      </p:sp>
+      <p:sp>
+        <p:nvSpPr>
+          <p:cNvPr id="6" name="Down Arrow 5"/>
+          <p:cNvSpPr/>
+          <p:nvPr/>
+        </p:nvSpPr>
+        <p:spPr>
+          <a:xfrm>
+            <a:off x="5852160" y="4983480"/>
+            <a:ext cx="457200" cy="320040"/>
+          </a:xfrm>
+          <a:prstGeom prst="downArrow">
+            <a:avLst/>
+          </a:prstGeom>
+          <a:solidFill>
+            <a:srgbClr val="0284C7"/>
+          </a:solidFill>
+          <a:ln>
+            <a:noFill/>
+          </a:ln>
+        </p:spPr>
+        <p:style>
+          <a:lnRef idx="1">
+            <a:schemeClr val="accent1"/>
+          </a:lnRef>
+          <a:fillRef idx="3">
+            <a:schemeClr val="accent1"/>
+          </a:fillRef>
+          <a:effectRef idx="2">
+            <a:schemeClr val="accent1"/>
+          </a:effectRef>
+          <a:fontRef idx="minor">
+            <a:schemeClr val="lt1"/>
+          </a:fontRef>
+        </p:style>
+        <p:txBody>
+          <a:bodyPr rtlCol="0" anchor="ctr"/>
+          <a:lstStyle/>
+          <a:p>
+            <a:pPr algn="ctr"/>
+          </a:p>
+        </p:txBody>
+      </p:sp>
+      <p:sp>
+        <p:nvSpPr>
+          <p:cNvPr id="7" name="Rounded Rectangle 6"/>
+          <p:cNvSpPr/>
+          <p:nvPr/>
+        </p:nvSpPr>
+        <p:spPr>
+          <a:xfrm>
+            <a:off x="731520" y="5394960"/>
+            <a:ext cx="10698480" cy="1188720"/>
+          </a:xfrm>
+          <a:prstGeom prst="roundRect">
+            <a:avLst/>
+          </a:prstGeom>
+          <a:solidFill>
+            <a:srgbClr val="F0FDF4"/>
+          </a:solidFill>
+          <a:ln w="19050">
+            <a:solidFill>
+              <a:srgbClr val="10955A"/>
+            </a:solidFill>
+          </a:ln>
+        </p:spPr>
+        <p:style>
+          <a:lnRef idx="1">
+            <a:schemeClr val="accent1"/>
+          </a:lnRef>
+          <a:fillRef idx="3">
+            <a:schemeClr val="accent1"/>
+          </a:fillRef>
+          <a:effectRef idx="2">
+            <a:schemeClr val="accent1"/>
+          </a:effectRef>
+          <a:fontRef idx="minor">
+            <a:schemeClr val="lt1"/>
+          </a:fontRef>
+        </p:style>
+        <p:txBody>
+          <a:bodyPr rtlCol="0" anchor="t" wrap="square" tIns="164592" lIns="182880" rIns="182880" bIns="164592"/>
+          <a:lstStyle/>
+          <a:p>
+            <a:pPr algn="ctr">
+              <a:spcAft>
+                <a:spcPts val="800"/>
+              </a:spcAft>
+              <a:defRPr sz="2200" b="1">
+                <a:solidFill>
+                  <a:srgbClr val="10955A"/>
+                </a:solidFill>
+                <a:latin typeface="Segoe UI"/>
+              </a:defRPr>
+            </a:pPr>
+            <a:r>
+              <a:t>Tier 3: Persistence Layer — SQLite WAL Mode + 4 B-Tree Indexes</a:t>
+            </a:r>
+          </a:p>
+          <a:p>
+            <a:pPr>
+              <a:spcAft>
+                <a:spcPts val="800"/>
+              </a:spcAft>
+              <a:defRPr sz="2000">
+                <a:solidFill>
+                  <a:srgbClr val="0F172A"/>
+                </a:solidFill>
+                <a:latin typeface="Segoe UI"/>
+              </a:defRPr>
+            </a:pPr>
+            <a:r>
+              <a:t>• ACID Transactions  │  WAL Concurrent Reads  │  PRAGMA foreign_keys = ON</a:t>
+            </a:r>
+          </a:p>
+          <a:p>
+            <a:pPr>
+              <a:spcAft>
+                <a:spcPts val="800"/>
+              </a:spcAft>
+              <a:defRPr sz="2000">
+                <a:solidFill>
+                  <a:srgbClr val="0F172A"/>
+                </a:solidFill>
+                <a:latin typeface="Segoe UI"/>
+              </a:defRPr>
+            </a:pPr>
+            <a:r>
+              <a:t>• B-Tree Indexes: idx_quizzes_cat  │  idx_quest_qid  │  idx_att_usr  │  idx_attempts_time</a:t>
+            </a:r>
+          </a:p>
+        </p:txBody>
+      </p:sp>
+    </p:spTree>
+  </p:cSld>
+  <p:clrMapOvr>
+    <a:masterClrMapping/>
+  </p:clrMapOvr>
+</p:sld>
+</file>
+
+<file path=ppt/slides/slide6.xml><?xml version="1.0" encoding="utf-8"?>
+<p:sld xmlns:a="http://schemas.openxmlformats.org/drawingml/2006/main" xmlns:p="http://schemas.openxmlformats.org/presentationml/2006/main" xmlns:r="http://schemas.openxmlformats.org/officeDocument/2006/relationships">
+  <p:cSld>
+    <p:bg>
+      <p:bgPr>
+        <a:solidFill>
+          <a:srgbClr val="F1F5F9"/>
+        </a:solidFill>
+        <a:effectLst/>
+      </p:bgPr>
+    </p:bg>
+    <p:spTree>
+      <p:nvGrpSpPr>
+        <p:cNvPr id="1" name=""/>
+        <p:cNvGrpSpPr/>
+        <p:nvPr/>
+      </p:nvGrpSpPr>
+      <p:grpSpPr/>
+      <p:sp>
+        <p:nvSpPr>
+          <p:cNvPr id="2" name="TextBox 1"/>
+          <p:cNvSpPr txBox="1"/>
+          <p:nvPr/>
+        </p:nvSpPr>
+        <p:spPr>
+          <a:xfrm>
+            <a:off x="731520" y="365760"/>
+            <a:ext cx="10698480" cy="1097280"/>
+          </a:xfrm>
+          <a:prstGeom prst="rect">
+            <a:avLst/>
+          </a:prstGeom>
+          <a:noFill/>
+        </p:spPr>
+        <p:txBody>
+          <a:bodyPr wrap="square" tIns="0" lIns="0" bIns="0" rIns="0">
+            <a:spAutoFit/>
+          </a:bodyPr>
+          <a:lstStyle/>
+          <a:p>
+            <a:pPr>
+              <a:spcAft>
+                <a:spcPts val="200"/>
+              </a:spcAft>
+              <a:defRPr sz="1300" b="1">
+                <a:solidFill>
+                  <a:srgbClr val="0284C7"/>
+                </a:solidFill>
+                <a:latin typeface="Segoe UI"/>
+              </a:defRPr>
+            </a:pPr>
+            <a:r>
+              <a:t>BBAT104 — TOTAL QUALITY MANAGEMENT (TQM)</a:t>
+            </a:r>
+          </a:p>
+          <a:p>
+            <a:pPr>
+              <a:defRPr sz="3800" b="1">
+                <a:solidFill>
+                  <a:srgbClr val="1E3A5F"/>
+                </a:solidFill>
+                <a:latin typeface="Segoe UI"/>
+              </a:defRPr>
+            </a:pPr>
+            <a:r>
+              <a:t>Five Q05 Latency-Reduction Features</a:t>
+            </a:r>
+          </a:p>
+        </p:txBody>
+      </p:sp>
+      <p:sp>
+        <p:nvSpPr>
+          <p:cNvPr id="3" name="Rounded Rectangle 2"/>
+          <p:cNvSpPr/>
+          <p:nvPr/>
+        </p:nvSpPr>
+        <p:spPr>
+          <a:xfrm>
+            <a:off x="731520" y="1645920"/>
+            <a:ext cx="5212080" cy="2194560"/>
+          </a:xfrm>
+          <a:prstGeom prst="roundRect">
+            <a:avLst/>
+          </a:prstGeom>
+          <a:solidFill>
+            <a:srgbClr val="FFFFFF"/>
+          </a:solidFill>
+          <a:ln w="19050">
+            <a:solidFill>
+              <a:srgbClr val="1E3A5F"/>
+            </a:solidFill>
+          </a:ln>
+        </p:spPr>
+        <p:style>
+          <a:lnRef idx="1">
+            <a:schemeClr val="accent1"/>
+          </a:lnRef>
+          <a:fillRef idx="3">
+            <a:schemeClr val="accent1"/>
+          </a:fillRef>
+          <a:effectRef idx="2">
+            <a:schemeClr val="accent1"/>
+          </a:effectRef>
+          <a:fontRef idx="minor">
+            <a:schemeClr val="lt1"/>
+          </a:fontRef>
+        </p:style>
+        <p:txBody>
+          <a:bodyPr rtlCol="0" anchor="t" wrap="square" tIns="164592" lIns="182880" rIns="182880" bIns="164592"/>
+          <a:lstStyle/>
+          <a:p>
+            <a:pPr algn="ctr">
+              <a:spcAft>
+                <a:spcPts val="800"/>
+              </a:spcAft>
+              <a:defRPr sz="2200" b="1">
+                <a:solidFill>
+                  <a:srgbClr val="1E3A5F"/>
+                </a:solidFill>
+                <a:latin typeface="Segoe UI"/>
+              </a:defRPr>
+            </a:pPr>
+            <a:r>
+              <a:t>1. Fast Search (Q05-F1)</a:t>
+            </a:r>
+          </a:p>
+          <a:p>
+            <a:pPr>
+              <a:spcAft>
+                <a:spcPts val="800"/>
+              </a:spcAft>
+              <a:defRPr sz="2000">
+                <a:solidFill>
+                  <a:srgbClr val="0F172A"/>
+                </a:solidFill>
+                <a:latin typeface="Segoe UI"/>
+              </a:defRPr>
+            </a:pPr>
+            <a:r>
+              <a:t>• B-Tree category index query</a:t>
+            </a:r>
+          </a:p>
+          <a:p>
+            <a:pPr>
+              <a:spcAft>
+                <a:spcPts val="800"/>
+              </a:spcAft>
+              <a:defRPr sz="2000">
+                <a:solidFill>
+                  <a:srgbClr val="0F172A"/>
+                </a:solidFill>
+                <a:latin typeface="Segoe UI"/>
+              </a:defRPr>
+            </a:pPr>
+            <a:r>
+              <a:t>• Input debouncing eliminates spam</a:t>
+            </a:r>
+          </a:p>
+          <a:p>
+            <a:pPr>
+              <a:spcAft>
+                <a:spcPts val="800"/>
+              </a:spcAft>
+              <a:defRPr sz="2000">
+                <a:solidFill>
+                  <a:srgbClr val="0F172A"/>
+                </a:solidFill>
+                <a:latin typeface="Segoe UI"/>
+              </a:defRPr>
+            </a:pPr>
+            <a:r>
+              <a:t>• Speed: 3.33 ms (SLA ≤ 40 ms)</a:t>
+            </a:r>
+          </a:p>
+        </p:txBody>
+      </p:sp>
+      <p:sp>
+        <p:nvSpPr>
+          <p:cNvPr id="4" name="Rounded Rectangle 3"/>
+          <p:cNvSpPr/>
+          <p:nvPr/>
+        </p:nvSpPr>
+        <p:spPr>
+          <a:xfrm>
+            <a:off x="6217920" y="1645920"/>
+            <a:ext cx="5212080" cy="2194560"/>
+          </a:xfrm>
+          <a:prstGeom prst="roundRect">
+            <a:avLst/>
+          </a:prstGeom>
+          <a:solidFill>
+            <a:srgbClr val="FFFFFF"/>
+          </a:solidFill>
+          <a:ln w="19050">
+            <a:solidFill>
+              <a:srgbClr val="1E3A5F"/>
+            </a:solidFill>
+          </a:ln>
+        </p:spPr>
+        <p:style>
+          <a:lnRef idx="1">
+            <a:schemeClr val="accent1"/>
+          </a:lnRef>
+          <a:fillRef idx="3">
+            <a:schemeClr val="accent1"/>
+          </a:fillRef>
+          <a:effectRef idx="2">
+            <a:schemeClr val="accent1"/>
+          </a:effectRef>
+          <a:fontRef idx="minor">
+            <a:schemeClr val="lt1"/>
+          </a:fontRef>
+        </p:style>
+        <p:txBody>
+          <a:bodyPr rtlCol="0" anchor="t" wrap="square" tIns="164592" lIns="182880" rIns="182880" bIns="164592"/>
+          <a:lstStyle/>
+          <a:p>
+            <a:pPr algn="ctr">
+              <a:spcAft>
+                <a:spcPts val="800"/>
+              </a:spcAft>
+              <a:defRPr sz="2200" b="1">
+                <a:solidFill>
+                  <a:srgbClr val="1E3A5F"/>
+                </a:solidFill>
+                <a:latin typeface="Segoe UI"/>
+              </a:defRPr>
+            </a:pPr>
+            <a:r>
+              <a:t>2. Quick Navigation (Q05-F2)</a:t>
+            </a:r>
+          </a:p>
+          <a:p>
+            <a:pPr>
+              <a:spcAft>
+                <a:spcPts val="800"/>
+              </a:spcAft>
+              <a:defRPr sz="2000">
+                <a:solidFill>
+                  <a:srgbClr val="0F172A"/>
+                </a:solidFill>
+                <a:latin typeface="Segoe UI"/>
+              </a:defRPr>
+            </a:pPr>
+            <a:r>
+              <a:t>• Pre-mounted frames in RAM</a:t>
+            </a:r>
+          </a:p>
+          <a:p>
+            <a:pPr>
+              <a:spcAft>
+                <a:spcPts val="800"/>
+              </a:spcAft>
+              <a:defRPr sz="2000">
+                <a:solidFill>
+                  <a:srgbClr val="0F172A"/>
+                </a:solidFill>
+                <a:latin typeface="Segoe UI"/>
+              </a:defRPr>
+            </a:pPr>
+            <a:r>
+              <a:t>• Keyboard shortcuts (Alt+D/Q/M/R)</a:t>
+            </a:r>
+          </a:p>
+          <a:p>
+            <a:pPr>
+              <a:spcAft>
+                <a:spcPts val="800"/>
+              </a:spcAft>
+              <a:defRPr sz="2000">
+                <a:solidFill>
+                  <a:srgbClr val="0F172A"/>
+                </a:solidFill>
+                <a:latin typeface="Segoe UI"/>
+              </a:defRPr>
+            </a:pPr>
+            <a:r>
+              <a:t>• Speed: &lt; 1 ms pointer swap</a:t>
+            </a:r>
+          </a:p>
+        </p:txBody>
+      </p:sp>
+      <p:sp>
+        <p:nvSpPr>
+          <p:cNvPr id="5" name="Rounded Rectangle 4"/>
+          <p:cNvSpPr/>
+          <p:nvPr/>
+        </p:nvSpPr>
+        <p:spPr>
+          <a:xfrm>
+            <a:off x="731520" y="4114800"/>
+            <a:ext cx="5212080" cy="2194560"/>
+          </a:xfrm>
+          <a:prstGeom prst="roundRect">
+            <a:avLst/>
+          </a:prstGeom>
+          <a:solidFill>
+            <a:srgbClr val="FFFFFF"/>
+          </a:solidFill>
+          <a:ln w="19050">
+            <a:solidFill>
+              <a:srgbClr val="1E3A5F"/>
+            </a:solidFill>
+          </a:ln>
+        </p:spPr>
+        <p:style>
+          <a:lnRef idx="1">
+            <a:schemeClr val="accent1"/>
+          </a:lnRef>
+          <a:fillRef idx="3">
+            <a:schemeClr val="accent1"/>
+          </a:fillRef>
+          <a:effectRef idx="2">
+            <a:schemeClr val="accent1"/>
+          </a:effectRef>
+          <a:fontRef idx="minor">
+            <a:schemeClr val="lt1"/>
+          </a:fontRef>
+        </p:style>
+        <p:txBody>
+          <a:bodyPr rtlCol="0" anchor="t" wrap="square" tIns="164592" lIns="182880" rIns="182880" bIns="164592"/>
+          <a:lstStyle/>
+          <a:p>
+            <a:pPr algn="ctr">
+              <a:spcAft>
+                <a:spcPts val="800"/>
+              </a:spcAft>
+              <a:defRPr sz="2200" b="1">
+                <a:solidFill>
+                  <a:srgbClr val="1E3A5F"/>
+                </a:solidFill>
+                <a:latin typeface="Segoe UI"/>
+              </a:defRPr>
+            </a:pPr>
+            <a:r>
+              <a:t>3. Cached Dashboard (Q05-F3)</a:t>
+            </a:r>
+          </a:p>
+          <a:p>
+            <a:pPr>
+              <a:spcAft>
+                <a:spcPts val="800"/>
+              </a:spcAft>
+              <a:defRPr sz="2000">
+                <a:solidFill>
+                  <a:srgbClr val="0F172A"/>
+                </a:solidFill>
+                <a:latin typeface="Segoe UI"/>
+              </a:defRPr>
+            </a:pPr>
+            <a:r>
+              <a:t>• RAM buffer with 60s TTL</a:t>
+            </a:r>
+          </a:p>
+          <a:p>
+            <a:pPr>
+              <a:spcAft>
+                <a:spcPts val="800"/>
+              </a:spcAft>
+              <a:defRPr sz="2000">
+                <a:solidFill>
+                  <a:srgbClr val="0F172A"/>
+                </a:solidFill>
+                <a:latin typeface="Segoe UI"/>
+              </a:defRPr>
+            </a:pPr>
+            <a:r>
+              <a:t>• Bypasses heavy disk calculations</a:t>
+            </a:r>
+          </a:p>
+          <a:p>
+            <a:pPr>
+              <a:spcAft>
+                <a:spcPts val="800"/>
+              </a:spcAft>
+              <a:defRPr sz="2000">
+                <a:solidFill>
+                  <a:srgbClr val="0F172A"/>
+                </a:solidFill>
+                <a:latin typeface="Segoe UI"/>
+              </a:defRPr>
+            </a:pPr>
+            <a:r>
+              <a:t>• Speed: 0.010 ms (SLA ≤ 15 ms)</a:t>
+            </a:r>
+          </a:p>
+        </p:txBody>
+      </p:sp>
+      <p:sp>
+        <p:nvSpPr>
+          <p:cNvPr id="6" name="Rounded Rectangle 5"/>
+          <p:cNvSpPr/>
+          <p:nvPr/>
+        </p:nvSpPr>
+        <p:spPr>
+          <a:xfrm>
+            <a:off x="6217920" y="4114800"/>
+            <a:ext cx="5212080" cy="2194560"/>
+          </a:xfrm>
+          <a:prstGeom prst="roundRect">
+            <a:avLst/>
+          </a:prstGeom>
+          <a:solidFill>
+            <a:srgbClr val="FFFFFF"/>
+          </a:solidFill>
+          <a:ln w="19050">
+            <a:solidFill>
+              <a:srgbClr val="1E3A5F"/>
+            </a:solidFill>
+          </a:ln>
+        </p:spPr>
+        <p:style>
+          <a:lnRef idx="1">
+            <a:schemeClr val="accent1"/>
+          </a:lnRef>
+          <a:fillRef idx="3">
+            <a:schemeClr val="accent1"/>
+          </a:fillRef>
+          <a:effectRef idx="2">
+            <a:schemeClr val="accent1"/>
+          </a:effectRef>
+          <a:fontRef idx="minor">
+            <a:schemeClr val="lt1"/>
+          </a:fontRef>
+        </p:style>
+        <p:txBody>
+          <a:bodyPr rtlCol="0" anchor="t" wrap="square" tIns="164592" lIns="182880" rIns="182880" bIns="164592"/>
+          <a:lstStyle/>
+          <a:p>
+            <a:pPr algn="ctr">
+              <a:spcAft>
+                <a:spcPts val="800"/>
+              </a:spcAft>
+              <a:defRPr sz="2200" b="1">
+                <a:solidFill>
+                  <a:srgbClr val="1E3A5F"/>
+                </a:solidFill>
+                <a:latin typeface="Segoe UI"/>
+              </a:defRPr>
+            </a:pPr>
+            <a:r>
+              <a:t>4. Database Indexing (Q05-F4)</a:t>
+            </a:r>
+          </a:p>
+          <a:p>
+            <a:pPr>
+              <a:spcAft>
+                <a:spcPts val="800"/>
+              </a:spcAft>
+              <a:defRPr sz="2000">
+                <a:solidFill>
+                  <a:srgbClr val="0F172A"/>
+                </a:solidFill>
+                <a:latin typeface="Segoe UI"/>
+              </a:defRPr>
+            </a:pPr>
+            <a:r>
+              <a:t>• 4 composite B-Tree indexes</a:t>
+            </a:r>
+          </a:p>
+          <a:p>
+            <a:pPr>
+              <a:spcAft>
+                <a:spcPts val="800"/>
+              </a:spcAft>
+              <a:defRPr sz="2000">
+                <a:solidFill>
+                  <a:srgbClr val="0F172A"/>
+                </a:solidFill>
+                <a:latin typeface="Segoe UI"/>
+              </a:defRPr>
+            </a:pPr>
+            <a:r>
+              <a:t>• Auto-created on application boot</a:t>
+            </a:r>
+          </a:p>
+          <a:p>
+            <a:pPr>
+              <a:spcAft>
+                <a:spcPts val="800"/>
+              </a:spcAft>
+              <a:defRPr sz="2000">
+                <a:solidFill>
+                  <a:srgbClr val="0F172A"/>
+                </a:solidFill>
+                <a:latin typeface="Segoe UI"/>
+              </a:defRPr>
+            </a:pPr>
+            <a:r>
+              <a:t>• Speed: O(log N) tree lookups</a:t>
+            </a:r>
+          </a:p>
+        </p:txBody>
+      </p:sp>
+    </p:spTree>
+  </p:cSld>
+  <p:clrMapOvr>
+    <a:masterClrMapping/>
+  </p:clrMapOvr>
+</p:sld>
+</file>
+
+<file path=ppt/slides/slide7.xml><?xml version="1.0" encoding="utf-8"?>
+<p:sld xmlns:a="http://schemas.openxmlformats.org/drawingml/2006/main" xmlns:p="http://schemas.openxmlformats.org/presentationml/2006/main" xmlns:r="http://schemas.openxmlformats.org/officeDocument/2006/relationships">
+  <p:cSld>
+    <p:bg>
+      <p:bgPr>
+        <a:solidFill>
+          <a:srgbClr val="F1F5F9"/>
+        </a:solidFill>
+        <a:effectLst/>
+      </p:bgPr>
+    </p:bg>
+    <p:spTree>
+      <p:nvGrpSpPr>
+        <p:cNvPr id="1" name=""/>
+        <p:cNvGrpSpPr/>
+        <p:nvPr/>
+      </p:nvGrpSpPr>
+      <p:grpSpPr/>
+      <p:sp>
+        <p:nvSpPr>
+          <p:cNvPr id="2" name="TextBox 1"/>
+          <p:cNvSpPr txBox="1"/>
+          <p:nvPr/>
+        </p:nvSpPr>
+        <p:spPr>
+          <a:xfrm>
+            <a:off x="731520" y="365760"/>
+            <a:ext cx="10698480" cy="1097280"/>
+          </a:xfrm>
+          <a:prstGeom prst="rect">
+            <a:avLst/>
+          </a:prstGeom>
+          <a:noFill/>
+        </p:spPr>
+        <p:txBody>
+          <a:bodyPr wrap="square" tIns="0" lIns="0" bIns="0" rIns="0">
+            <a:spAutoFit/>
+          </a:bodyPr>
+          <a:lstStyle/>
+          <a:p>
+            <a:pPr>
+              <a:spcAft>
+                <a:spcPts val="200"/>
+              </a:spcAft>
+              <a:defRPr sz="1300" b="1">
+                <a:solidFill>
+                  <a:srgbClr val="0284C7"/>
+                </a:solidFill>
+                <a:latin typeface="Segoe UI"/>
+              </a:defRPr>
+            </a:pPr>
+            <a:r>
+              <a:t>BBAT104 — TOTAL QUALITY MANAGEMENT (TQM)</a:t>
+            </a:r>
+          </a:p>
+          <a:p>
+            <a:pPr>
+              <a:defRPr sz="3800" b="1">
+                <a:solidFill>
+                  <a:srgbClr val="1E3A5F"/>
+                </a:solidFill>
+                <a:latin typeface="Segoe UI"/>
+              </a:defRPr>
+            </a:pPr>
+            <a:r>
+              <a:t>Poka-Yoke (Mistake-Proofing) Architecture</a:t>
+            </a:r>
+          </a:p>
+        </p:txBody>
+      </p:sp>
+      <p:sp>
+        <p:nvSpPr>
+          <p:cNvPr id="3" name="Rounded Rectangle 2"/>
+          <p:cNvSpPr/>
+          <p:nvPr/>
+        </p:nvSpPr>
+        <p:spPr>
+          <a:xfrm>
+            <a:off x="731520" y="1645920"/>
+            <a:ext cx="5120640" cy="4572000"/>
+          </a:xfrm>
+          <a:prstGeom prst="roundRect">
+            <a:avLst/>
+          </a:prstGeom>
+          <a:solidFill>
+            <a:srgbClr val="FFFFFF"/>
+          </a:solidFill>
+          <a:ln w="19050">
+            <a:solidFill>
+              <a:srgbClr val="10955A"/>
+            </a:solidFill>
+          </a:ln>
+        </p:spPr>
+        <p:style>
+          <a:lnRef idx="1">
+            <a:schemeClr val="accent1"/>
+          </a:lnRef>
+          <a:fillRef idx="3">
+            <a:schemeClr val="accent1"/>
+          </a:fillRef>
+          <a:effectRef idx="2">
+            <a:schemeClr val="accent1"/>
+          </a:effectRef>
+          <a:fontRef idx="minor">
+            <a:schemeClr val="lt1"/>
+          </a:fontRef>
+        </p:style>
+        <p:txBody>
+          <a:bodyPr rtlCol="0" anchor="t" wrap="square" tIns="164592" lIns="182880" rIns="182880" bIns="164592"/>
+          <a:lstStyle/>
+          <a:p>
+            <a:pPr algn="ctr">
+              <a:spcAft>
+                <a:spcPts val="800"/>
+              </a:spcAft>
+              <a:defRPr sz="2200" b="1">
+                <a:solidFill>
+                  <a:srgbClr val="10955A"/>
+                </a:solidFill>
+                <a:latin typeface="Segoe UI"/>
+              </a:defRPr>
+            </a:pPr>
+            <a:r>
+              <a:t>Form &amp; Data-Entry Controls</a:t>
+            </a:r>
+          </a:p>
+          <a:p>
+            <a:pPr>
+              <a:spcAft>
+                <a:spcPts val="800"/>
+              </a:spcAft>
+              <a:defRPr sz="2000">
+                <a:solidFill>
+                  <a:srgbClr val="0F172A"/>
+                </a:solidFill>
+                <a:latin typeface="Segoe UI"/>
+              </a:defRPr>
+            </a:pPr>
+            <a:r>
+              <a:t>• Restricted Answer Keys: Dropdown strictly constrained to ['A', 'B', 'C', 'D'].</a:t>
+            </a:r>
+          </a:p>
+          <a:p>
+            <a:pPr>
+              <a:spcAft>
+                <a:spcPts val="800"/>
+              </a:spcAft>
+              <a:defRPr sz="2000">
+                <a:solidFill>
+                  <a:srgbClr val="0F172A"/>
+                </a:solidFill>
+                <a:latin typeface="Segoe UI"/>
+              </a:defRPr>
+            </a:pPr>
+            <a:r>
+              <a:t>• Blank Input Blocking: System prevents saving empty prompts or options.</a:t>
+            </a:r>
+          </a:p>
+          <a:p>
+            <a:pPr>
+              <a:spcAft>
+                <a:spcPts val="800"/>
+              </a:spcAft>
+              <a:defRPr sz="2000">
+                <a:solidFill>
+                  <a:srgbClr val="0F172A"/>
+                </a:solidFill>
+                <a:latin typeface="Segoe UI"/>
+              </a:defRPr>
+            </a:pPr>
+            <a:r>
+              <a:t>• Boundary Enforcement: Negative duration &amp; pass score rejected by DB CHECK.</a:t>
+            </a:r>
+          </a:p>
+          <a:p>
+            <a:pPr>
+              <a:spcAft>
+                <a:spcPts val="800"/>
+              </a:spcAft>
+              <a:defRPr sz="2000">
+                <a:solidFill>
+                  <a:srgbClr val="0F172A"/>
+                </a:solidFill>
+                <a:latin typeface="Segoe UI"/>
+              </a:defRPr>
+            </a:pPr>
+            <a:r>
+              <a:t>• Concept: Errors are stopped at the source before entering database.</a:t>
+            </a:r>
+          </a:p>
+        </p:txBody>
+      </p:sp>
+      <p:sp>
+        <p:nvSpPr>
+          <p:cNvPr id="4" name="Rounded Rectangle 3"/>
+          <p:cNvSpPr/>
+          <p:nvPr/>
+        </p:nvSpPr>
+        <p:spPr>
+          <a:xfrm>
+            <a:off x="6217920" y="1645920"/>
+            <a:ext cx="5212080" cy="4572000"/>
+          </a:xfrm>
+          <a:prstGeom prst="roundRect">
+            <a:avLst/>
+          </a:prstGeom>
+          <a:solidFill>
+            <a:srgbClr val="FFFFFF"/>
+          </a:solidFill>
+          <a:ln w="19050">
+            <a:solidFill>
+              <a:srgbClr val="10955A"/>
+            </a:solidFill>
+          </a:ln>
+        </p:spPr>
+        <p:style>
+          <a:lnRef idx="1">
+            <a:schemeClr val="accent1"/>
+          </a:lnRef>
+          <a:fillRef idx="3">
+            <a:schemeClr val="accent1"/>
+          </a:fillRef>
+          <a:effectRef idx="2">
+            <a:schemeClr val="accent1"/>
+          </a:effectRef>
+          <a:fontRef idx="minor">
+            <a:schemeClr val="lt1"/>
+          </a:fontRef>
+        </p:style>
+        <p:txBody>
+          <a:bodyPr rtlCol="0" anchor="t" wrap="square" tIns="164592" lIns="182880" rIns="182880" bIns="164592"/>
+          <a:lstStyle/>
+          <a:p>
+            <a:pPr algn="ctr">
+              <a:spcAft>
+                <a:spcPts val="800"/>
+              </a:spcAft>
+              <a:defRPr sz="2200" b="1">
+                <a:solidFill>
+                  <a:srgbClr val="10955A"/>
+                </a:solidFill>
+                <a:latin typeface="Segoe UI"/>
+              </a:defRPr>
+            </a:pPr>
+            <a:r>
+              <a:t>Operational &amp; Runtime Controls</a:t>
+            </a:r>
+          </a:p>
+          <a:p>
+            <a:pPr>
+              <a:spcAft>
+                <a:spcPts val="800"/>
+              </a:spcAft>
+              <a:defRPr sz="2000">
+                <a:solidFill>
+                  <a:srgbClr val="0F172A"/>
+                </a:solidFill>
+                <a:latin typeface="Segoe UI"/>
+              </a:defRPr>
+            </a:pPr>
+            <a:r>
+              <a:t>• Double-Click Guard: Submit button disables to stop duplicate attempts.</a:t>
+            </a:r>
+          </a:p>
+          <a:p>
+            <a:pPr>
+              <a:spcAft>
+                <a:spcPts val="800"/>
+              </a:spcAft>
+              <a:defRPr sz="2000">
+                <a:solidFill>
+                  <a:srgbClr val="0F172A"/>
+                </a:solidFill>
+                <a:latin typeface="Segoe UI"/>
+              </a:defRPr>
+            </a:pPr>
+            <a:r>
+              <a:t>• Auto Timer Commit: Background daemon auto-submits quiz at 00:00.</a:t>
+            </a:r>
+          </a:p>
+          <a:p>
+            <a:pPr>
+              <a:spcAft>
+                <a:spcPts val="800"/>
+              </a:spcAft>
+              <a:defRPr sz="2000">
+                <a:solidFill>
+                  <a:srgbClr val="0F172A"/>
+                </a:solidFill>
+                <a:latin typeface="Segoe UI"/>
+              </a:defRPr>
+            </a:pPr>
+            <a:r>
+              <a:t>• Role Deletion Guard: Only Admins can delete active quizzes.</a:t>
+            </a:r>
+          </a:p>
+          <a:p>
+            <a:pPr>
+              <a:spcAft>
+                <a:spcPts val="800"/>
+              </a:spcAft>
+              <a:defRPr sz="2000">
+                <a:solidFill>
+                  <a:srgbClr val="0F172A"/>
+                </a:solidFill>
+                <a:latin typeface="Segoe UI"/>
+              </a:defRPr>
+            </a:pPr>
+            <a:r>
+              <a:t>• Index Self-Healing: Startup routine verifies indexes exist.</a:t>
+            </a:r>
+          </a:p>
+        </p:txBody>
+      </p:sp>
+    </p:spTree>
+  </p:cSld>
+  <p:clrMapOvr>
+    <a:masterClrMapping/>
+  </p:clrMapOvr>
+</p:sld>
+</file>
+
+<file path=ppt/slides/slide8.xml><?xml version="1.0" encoding="utf-8"?>
+<p:sld xmlns:a="http://schemas.openxmlformats.org/drawingml/2006/main" xmlns:p="http://schemas.openxmlformats.org/presentationml/2006/main" xmlns:r="http://schemas.openxmlformats.org/officeDocument/2006/relationships">
+  <p:cSld>
+    <p:bg>
+      <p:bgPr>
+        <a:solidFill>
+          <a:srgbClr val="F1F5F9"/>
+        </a:solidFill>
+        <a:effectLst/>
+      </p:bgPr>
+    </p:bg>
+    <p:spTree>
+      <p:nvGrpSpPr>
+        <p:cNvPr id="1" name=""/>
+        <p:cNvGrpSpPr/>
+        <p:nvPr/>
+      </p:nvGrpSpPr>
+      <p:grpSpPr/>
+      <p:sp>
+        <p:nvSpPr>
+          <p:cNvPr id="2" name="TextBox 1"/>
+          <p:cNvSpPr txBox="1"/>
+          <p:nvPr/>
+        </p:nvSpPr>
+        <p:spPr>
+          <a:xfrm>
+            <a:off x="731520" y="365760"/>
+            <a:ext cx="10698480" cy="1097280"/>
+          </a:xfrm>
+          <a:prstGeom prst="rect">
+            <a:avLst/>
+          </a:prstGeom>
+          <a:noFill/>
+        </p:spPr>
+        <p:txBody>
+          <a:bodyPr wrap="square" tIns="0" lIns="0" bIns="0" rIns="0">
+            <a:spAutoFit/>
+          </a:bodyPr>
+          <a:lstStyle/>
+          <a:p>
+            <a:pPr>
+              <a:spcAft>
+                <a:spcPts val="200"/>
+              </a:spcAft>
+              <a:defRPr sz="1300" b="1">
+                <a:solidFill>
+                  <a:srgbClr val="0284C7"/>
+                </a:solidFill>
+                <a:latin typeface="Segoe UI"/>
+              </a:defRPr>
+            </a:pPr>
+            <a:r>
+              <a:t>BBAT104 — TOTAL QUALITY MANAGEMENT (TQM)</a:t>
+            </a:r>
+          </a:p>
+          <a:p>
+            <a:pPr>
+              <a:defRPr sz="3800" b="1">
+                <a:solidFill>
+                  <a:srgbClr val="1E3A5F"/>
+                </a:solidFill>
+                <a:latin typeface="Segoe UI"/>
+              </a:defRPr>
+            </a:pPr>
+            <a:r>
+              <a:t>Empirical Benchmarks &amp; SLA Verification</a:t>
             </a:r>
           </a:p>
         </p:txBody>
@@ -4150,7 +5778,7 @@
               </a:defRPr>
             </a:pPr>
             <a:r>
-              <a:t>SLA Benchmarks &amp; Automated Pytest Suite</a:t>
+              <a:t>Measured Speeds vs. Upper Specification Limits (USL)</a:t>
             </a:r>
           </a:p>
           <a:p>
@@ -4166,7 +5794,7 @@
               </a:defRPr>
             </a:pPr>
             <a:r>
-              <a:t>• 1. Catalog Fast Search: 3.33 ms  (Target SLA ≤ 40.0 ms)  →  92% margin PASS</a:t>
+              <a:t>• 1. Fast Catalog Search (Q05-F1): Measured 3.33 ms  │  USL ≤ 40.0 ms  │  PASS (92% safety margin)</a:t>
             </a:r>
           </a:p>
           <a:p>
@@ -4182,7 +5810,7 @@
               </a:defRPr>
             </a:pPr>
             <a:r>
-              <a:t>• 2. In-Memory Quiz Load: 2.09 ms  (Target SLA ≤ 50.0 ms)  →  95% margin PASS</a:t>
+              <a:t>• 2. Question Load into RAM (Q05-F2): Measured 2.09 ms  │  USL ≤ 50.0 ms  │  PASS (95% safety margin)</a:t>
             </a:r>
           </a:p>
           <a:p>
@@ -4198,7 +5826,7 @@
               </a:defRPr>
             </a:pPr>
             <a:r>
-              <a:t>• 3. Cached Dashboard: 0.010 ms  (Target SLA ≤ 15.0 ms)  →  99.9% margin PASS</a:t>
+              <a:t>• 3. Cached Dashboard Read (Q05-F3): Measured 0.010 ms  │  USL ≤ 15.0 ms  │  PASS (99.9% safety margin)</a:t>
             </a:r>
           </a:p>
           <a:p>
@@ -4214,7 +5842,7 @@
               </a:defRPr>
             </a:pPr>
             <a:r>
-              <a:t>• 4. Paginated Reports: 5.71 ms  (Target SLA ≤ 50.0 ms)  →  88% margin PASS</a:t>
+              <a:t>• 4. Paginated Report Stream (Q05-F5): Measured 5.71 ms  │  USL ≤ 50.0 ms  │  PASS (88% safety margin)</a:t>
             </a:r>
           </a:p>
           <a:p>
@@ -4230,7 +5858,7 @@
               </a:defRPr>
             </a:pPr>
             <a:r>
-              <a:t>• 5. Automated Test Proof: 12/12 automated pytest unit and performance tests pass in 1.99s.</a:t>
+              <a:t>• 5. Atomic Submit &amp; Scoring: Measured 99.09 ms  │  USL ≤ 100.0 ms  │  PASS (Zero defect conformance)</a:t>
             </a:r>
           </a:p>
           <a:p>
@@ -4246,7 +5874,372 @@
               </a:defRPr>
             </a:pPr>
             <a:r>
-              <a:t>• Summary: 100% SLA compliance with zero defects for Reviews 1 and 2.</a:t>
+              <a:t>• Automated Test Proof: 12/12 automated pytest unit and performance tests pass in 1.99s.</a:t>
+            </a:r>
+          </a:p>
+        </p:txBody>
+      </p:sp>
+    </p:spTree>
+  </p:cSld>
+  <p:clrMapOvr>
+    <a:masterClrMapping/>
+  </p:clrMapOvr>
+</p:sld>
+</file>
+
+<file path=ppt/slides/slide9.xml><?xml version="1.0" encoding="utf-8"?>
+<p:sld xmlns:a="http://schemas.openxmlformats.org/drawingml/2006/main" xmlns:p="http://schemas.openxmlformats.org/presentationml/2006/main" xmlns:r="http://schemas.openxmlformats.org/officeDocument/2006/relationships">
+  <p:cSld>
+    <p:bg>
+      <p:bgPr>
+        <a:solidFill>
+          <a:srgbClr val="F1F5F9"/>
+        </a:solidFill>
+        <a:effectLst/>
+      </p:bgPr>
+    </p:bg>
+    <p:spTree>
+      <p:nvGrpSpPr>
+        <p:cNvPr id="1" name=""/>
+        <p:cNvGrpSpPr/>
+        <p:nvPr/>
+      </p:nvGrpSpPr>
+      <p:grpSpPr/>
+      <p:sp>
+        <p:nvSpPr>
+          <p:cNvPr id="2" name="TextBox 1"/>
+          <p:cNvSpPr txBox="1"/>
+          <p:nvPr/>
+        </p:nvSpPr>
+        <p:spPr>
+          <a:xfrm>
+            <a:off x="731520" y="365760"/>
+            <a:ext cx="10698480" cy="1097280"/>
+          </a:xfrm>
+          <a:prstGeom prst="rect">
+            <a:avLst/>
+          </a:prstGeom>
+          <a:noFill/>
+        </p:spPr>
+        <p:txBody>
+          <a:bodyPr wrap="square" tIns="0" lIns="0" bIns="0" rIns="0">
+            <a:spAutoFit/>
+          </a:bodyPr>
+          <a:lstStyle/>
+          <a:p>
+            <a:pPr>
+              <a:spcAft>
+                <a:spcPts val="200"/>
+              </a:spcAft>
+              <a:defRPr sz="1300" b="1">
+                <a:solidFill>
+                  <a:srgbClr val="0284C7"/>
+                </a:solidFill>
+                <a:latin typeface="Segoe UI"/>
+              </a:defRPr>
+            </a:pPr>
+            <a:r>
+              <a:t>BBAT104 — TOTAL QUALITY MANAGEMENT (TQM)</a:t>
+            </a:r>
+          </a:p>
+          <a:p>
+            <a:pPr>
+              <a:defRPr sz="3800" b="1">
+                <a:solidFill>
+                  <a:srgbClr val="1E3A5F"/>
+                </a:solidFill>
+                <a:latin typeface="Segoe UI"/>
+              </a:defRPr>
+            </a:pPr>
+            <a:r>
+              <a:t>Summary &amp; Review Roadmap</a:t>
+            </a:r>
+          </a:p>
+        </p:txBody>
+      </p:sp>
+      <p:sp>
+        <p:nvSpPr>
+          <p:cNvPr id="3" name="Rounded Rectangle 2"/>
+          <p:cNvSpPr/>
+          <p:nvPr/>
+        </p:nvSpPr>
+        <p:spPr>
+          <a:xfrm>
+            <a:off x="731520" y="1645920"/>
+            <a:ext cx="5120640" cy="4572000"/>
+          </a:xfrm>
+          <a:prstGeom prst="roundRect">
+            <a:avLst/>
+          </a:prstGeom>
+          <a:solidFill>
+            <a:srgbClr val="F0FDF4"/>
+          </a:solidFill>
+          <a:ln w="19050">
+            <a:solidFill>
+              <a:srgbClr val="10955A"/>
+            </a:solidFill>
+          </a:ln>
+        </p:spPr>
+        <p:style>
+          <a:lnRef idx="1">
+            <a:schemeClr val="accent1"/>
+          </a:lnRef>
+          <a:fillRef idx="3">
+            <a:schemeClr val="accent1"/>
+          </a:fillRef>
+          <a:effectRef idx="2">
+            <a:schemeClr val="accent1"/>
+          </a:effectRef>
+          <a:fontRef idx="minor">
+            <a:schemeClr val="lt1"/>
+          </a:fontRef>
+        </p:style>
+        <p:txBody>
+          <a:bodyPr rtlCol="0" anchor="t" wrap="square" tIns="164592" lIns="182880" rIns="182880" bIns="164592"/>
+          <a:lstStyle/>
+          <a:p>
+            <a:pPr algn="ctr">
+              <a:spcAft>
+                <a:spcPts val="800"/>
+              </a:spcAft>
+              <a:defRPr sz="2200" b="1">
+                <a:solidFill>
+                  <a:srgbClr val="10955A"/>
+                </a:solidFill>
+                <a:latin typeface="Segoe UI"/>
+              </a:defRPr>
+            </a:pPr>
+            <a:r>
+              <a:t>Reviews 1 &amp; 2 Completed</a:t>
+            </a:r>
+          </a:p>
+          <a:p>
+            <a:pPr>
+              <a:spcAft>
+                <a:spcPts val="800"/>
+              </a:spcAft>
+              <a:defRPr sz="2000">
+                <a:solidFill>
+                  <a:srgbClr val="0F172A"/>
+                </a:solidFill>
+                <a:latin typeface="Segoe UI"/>
+              </a:defRPr>
+            </a:pPr>
+            <a:r>
+              <a:t>• Review 1 (10 Marks): SRS, System Architecture, CTQ Tree, SIPOC Process Map.</a:t>
+            </a:r>
+          </a:p>
+          <a:p>
+            <a:pPr>
+              <a:spcAft>
+                <a:spcPts val="800"/>
+              </a:spcAft>
+              <a:defRPr sz="2000">
+                <a:solidFill>
+                  <a:srgbClr val="0F172A"/>
+                </a:solidFill>
+                <a:latin typeface="Segoe UI"/>
+              </a:defRPr>
+            </a:pPr>
+            <a:r>
+              <a:t>• Review 2 (15 Marks): Base CRUD modules, 5 Q05 features, B-Tree indexes, WAL mode.</a:t>
+            </a:r>
+          </a:p>
+          <a:p>
+            <a:pPr>
+              <a:spcAft>
+                <a:spcPts val="800"/>
+              </a:spcAft>
+              <a:defRPr sz="2000">
+                <a:solidFill>
+                  <a:srgbClr val="0F172A"/>
+                </a:solidFill>
+                <a:latin typeface="Segoe UI"/>
+              </a:defRPr>
+            </a:pPr>
+            <a:r>
+              <a:t>• Poka-Yoke error prevention fully operational at form &amp; DB levels.</a:t>
+            </a:r>
+          </a:p>
+          <a:p>
+            <a:pPr>
+              <a:spcAft>
+                <a:spcPts val="800"/>
+              </a:spcAft>
+              <a:defRPr sz="2000">
+                <a:solidFill>
+                  <a:srgbClr val="0F172A"/>
+                </a:solidFill>
+                <a:latin typeface="Segoe UI"/>
+              </a:defRPr>
+            </a:pPr>
+            <a:r>
+              <a:t>• Total 25/25 Raw Marks delivered on schedule.</a:t>
+            </a:r>
+          </a:p>
+        </p:txBody>
+      </p:sp>
+      <p:sp>
+        <p:nvSpPr>
+          <p:cNvPr id="4" name="Right Arrow 3"/>
+          <p:cNvSpPr/>
+          <p:nvPr/>
+        </p:nvSpPr>
+        <p:spPr>
+          <a:xfrm>
+            <a:off x="5943600" y="3749039"/>
+            <a:ext cx="365760" cy="320040"/>
+          </a:xfrm>
+          <a:prstGeom prst="rightArrow">
+            <a:avLst/>
+          </a:prstGeom>
+          <a:solidFill>
+            <a:srgbClr val="0284C7"/>
+          </a:solidFill>
+          <a:ln>
+            <a:noFill/>
+          </a:ln>
+        </p:spPr>
+        <p:style>
+          <a:lnRef idx="1">
+            <a:schemeClr val="accent1"/>
+          </a:lnRef>
+          <a:fillRef idx="3">
+            <a:schemeClr val="accent1"/>
+          </a:fillRef>
+          <a:effectRef idx="2">
+            <a:schemeClr val="accent1"/>
+          </a:effectRef>
+          <a:fontRef idx="minor">
+            <a:schemeClr val="lt1"/>
+          </a:fontRef>
+        </p:style>
+        <p:txBody>
+          <a:bodyPr rtlCol="0" anchor="ctr"/>
+          <a:lstStyle/>
+          <a:p>
+            <a:pPr algn="ctr"/>
+          </a:p>
+        </p:txBody>
+      </p:sp>
+      <p:sp>
+        <p:nvSpPr>
+          <p:cNvPr id="5" name="Rounded Rectangle 4"/>
+          <p:cNvSpPr/>
+          <p:nvPr/>
+        </p:nvSpPr>
+        <p:spPr>
+          <a:xfrm>
+            <a:off x="6400800" y="1645920"/>
+            <a:ext cx="5029200" cy="4572000"/>
+          </a:xfrm>
+          <a:prstGeom prst="roundRect">
+            <a:avLst/>
+          </a:prstGeom>
+          <a:solidFill>
+            <a:srgbClr val="FFFFFF"/>
+          </a:solidFill>
+          <a:ln w="19050">
+            <a:solidFill>
+              <a:srgbClr val="1E3A5F"/>
+            </a:solidFill>
+          </a:ln>
+        </p:spPr>
+        <p:style>
+          <a:lnRef idx="1">
+            <a:schemeClr val="accent1"/>
+          </a:lnRef>
+          <a:fillRef idx="3">
+            <a:schemeClr val="accent1"/>
+          </a:fillRef>
+          <a:effectRef idx="2">
+            <a:schemeClr val="accent1"/>
+          </a:effectRef>
+          <a:fontRef idx="minor">
+            <a:schemeClr val="lt1"/>
+          </a:fontRef>
+        </p:style>
+        <p:txBody>
+          <a:bodyPr rtlCol="0" anchor="t" wrap="square" tIns="164592" lIns="182880" rIns="182880" bIns="164592"/>
+          <a:lstStyle/>
+          <a:p>
+            <a:pPr algn="ctr">
+              <a:spcAft>
+                <a:spcPts val="800"/>
+              </a:spcAft>
+              <a:defRPr sz="2200" b="1">
+                <a:solidFill>
+                  <a:srgbClr val="1E3A5F"/>
+                </a:solidFill>
+                <a:latin typeface="Segoe UI"/>
+              </a:defRPr>
+            </a:pPr>
+            <a:r>
+              <a:t>Roadmap for Reviews 3 &amp; 4</a:t>
+            </a:r>
+          </a:p>
+          <a:p>
+            <a:pPr>
+              <a:spcAft>
+                <a:spcPts val="800"/>
+              </a:spcAft>
+              <a:defRPr sz="2000">
+                <a:solidFill>
+                  <a:srgbClr val="0F172A"/>
+                </a:solidFill>
+                <a:latin typeface="Segoe UI"/>
+              </a:defRPr>
+            </a:pPr>
+            <a:r>
+              <a:t>• Review 3 (15 Marks): Risk Analysis &amp; FMEA Matrix with RPN scores, defect logging.</a:t>
+            </a:r>
+          </a:p>
+          <a:p>
+            <a:pPr>
+              <a:spcAft>
+                <a:spcPts val="800"/>
+              </a:spcAft>
+              <a:defRPr sz="2000">
+                <a:solidFill>
+                  <a:srgbClr val="0F172A"/>
+                </a:solidFill>
+                <a:latin typeface="Segoe UI"/>
+              </a:defRPr>
+            </a:pPr>
+            <a:r>
+              <a:t>• Review 4 (15 Marks): Statistical Quality Control (SQC), Pareto Analysis (80/20), PDCA cycle.</a:t>
+            </a:r>
+          </a:p>
+          <a:p>
+            <a:pPr>
+              <a:spcAft>
+                <a:spcPts val="800"/>
+              </a:spcAft>
+              <a:defRPr sz="2000">
+                <a:solidFill>
+                  <a:srgbClr val="0F172A"/>
+                </a:solidFill>
+                <a:latin typeface="Segoe UI"/>
+              </a:defRPr>
+            </a:pPr>
+            <a:r>
+              <a:t>• Final Viva (10 Marks): Live software demonstration and TQM defense.</a:t>
+            </a:r>
+          </a:p>
+          <a:p>
+            <a:pPr>
+              <a:spcAft>
+                <a:spcPts val="800"/>
+              </a:spcAft>
+              <a:defRPr sz="2000">
+                <a:solidFill>
+                  <a:srgbClr val="0F172A"/>
+                </a:solidFill>
+                <a:latin typeface="Segoe UI"/>
+              </a:defRPr>
+            </a:pPr>
+            <a:r>
+              <a:t>• Documentation (5 Marks): Commit hygiene &amp; manual.</a:t>
             </a:r>
           </a:p>
         </p:txBody>

</xml_diff>